<commit_message>
added context measure demo
</commit_message>
<xml_diff>
--- a/presentation/Context_Engineering_y_Ambiguedad_final_matematica.pptx
+++ b/presentation/Context_Engineering_y_Ambiguedad_final_matematica.pptx
@@ -18,8 +18,9 @@
     <p:sldId xmlns:r="http://schemas.openxmlformats.org/officeDocument/2006/relationships" id="264" r:id="R24da019563f14abc"/>
     <p:sldId xmlns:ns0="http://schemas.openxmlformats.org/officeDocument/2006/relationships" id="276" ns0:id="rId26"/>
     <p:sldId xmlns:r="http://schemas.openxmlformats.org/officeDocument/2006/relationships" id="263" r:id="Ree5882ce0abe4856"/>
+    <p:sldId xmlns:ns0="http://schemas.openxmlformats.org/officeDocument/2006/relationships" id="277" ns0:id="rId27"/>
+    <p:sldId xmlns:ns0="http://schemas.openxmlformats.org/officeDocument/2006/relationships" id="278" ns0:id="rId28"/>
     <p:sldId xmlns:r="http://schemas.openxmlformats.org/officeDocument/2006/relationships" id="265" r:id="Re99384254a5449c7"/>
-    <p:sldId xmlns:ns0="http://schemas.openxmlformats.org/officeDocument/2006/relationships" id="277" ns0:id="rId27"/>
     <p:sldId xmlns:r="http://schemas.openxmlformats.org/officeDocument/2006/relationships" id="266" r:id="R39668b713c584295"/>
     <p:sldId xmlns:r="http://schemas.openxmlformats.org/officeDocument/2006/relationships" id="267" r:id="R00f6c99dd4a24a8b"/>
     <p:sldId xmlns:r="http://schemas.openxmlformats.org/officeDocument/2006/relationships" id="268" r:id="Rf7d46cb0562c4b19"/>
@@ -4089,7 +4090,7 @@
                 </a:solidFill>
                 <a:latin typeface="Aptos"/>
               </a:rPr>
-              <a:t>11</a:t>
+              <a:t>13</a:t>
             </a:r>
           </a:p>
         </p:txBody>
@@ -4178,7 +4179,7 @@
                 </a:solidFill>
                 <a:latin typeface="Aptos"/>
               </a:rPr>
-              <a:t>13 / INTENCIÓN LATENTE</a:t>
+              <a:t>14 / INTENCIÓN LATENTE</a:t>
             </a:r>
           </a:p>
         </p:txBody>
@@ -4573,7 +4574,7 @@
           </a:ln>
         </p:spPr>
         <p:txBody>
-          <a:bodyPr xmlns:a="http://schemas.openxmlformats.org/drawingml/2006/main" wrap="square" lIns="0" tIns="0" rIns="0" bIns="0" anchor="ctr">
+          <a:bodyPr xmlns:a="http://schemas.openxmlformats.org/drawingml/2006/main" wrap="square" lIns="0" tIns="0" rIns="0" bIns="0" anchor="t">
             <a:normAutofit fontScale="100000"/>
           </a:bodyPr>
           <a:lstStyle xmlns:a="http://schemas.openxmlformats.org/drawingml/2006/main"/>
@@ -4593,11 +4594,13 @@
               </a:defRPr>
             </a:pPr>
             <a:r>
-              <a:rPr sz="1800" b="1">
-                <a:solidFill>
-                  <a:srgbClr val="7065E8"/>
-                </a:solidFill>
-                <a:latin typeface="Aptos Display"/>
+              <a:rPr sz="1400" b="1" i="0">
+                <a:solidFill>
+                  <a:srgbClr val="3DD6C6"/>
+                </a:solidFill>
+                <a:latin typeface="Aptos"/>
+                <a:ea typeface="Aptos"/>
+                <a:cs typeface="Aptos"/>
               </a:rPr>
               <a:t>40%</a:t>
             </a:r>
@@ -4738,7 +4741,7 @@
           </a:ln>
         </p:spPr>
         <p:txBody>
-          <a:bodyPr xmlns:a="http://schemas.openxmlformats.org/drawingml/2006/main" wrap="square" lIns="0" tIns="0" rIns="0" bIns="0" anchor="ctr">
+          <a:bodyPr xmlns:a="http://schemas.openxmlformats.org/drawingml/2006/main" wrap="square" lIns="0" tIns="0" rIns="0" bIns="0" anchor="t">
             <a:normAutofit fontScale="100000"/>
           </a:bodyPr>
           <a:lstStyle xmlns:a="http://schemas.openxmlformats.org/drawingml/2006/main"/>
@@ -4758,11 +4761,13 @@
               </a:defRPr>
             </a:pPr>
             <a:r>
-              <a:rPr sz="1800" b="1">
+              <a:rPr sz="1400" b="1" i="0">
                 <a:solidFill>
                   <a:srgbClr val="7065E8"/>
                 </a:solidFill>
-                <a:latin typeface="Aptos Display"/>
+                <a:latin typeface="Aptos"/>
+                <a:ea typeface="Aptos"/>
+                <a:cs typeface="Aptos"/>
               </a:rPr>
               <a:t>35%</a:t>
             </a:r>
@@ -4903,7 +4908,7 @@
           </a:ln>
         </p:spPr>
         <p:txBody>
-          <a:bodyPr xmlns:a="http://schemas.openxmlformats.org/drawingml/2006/main" wrap="square" lIns="0" tIns="0" rIns="0" bIns="0" anchor="ctr">
+          <a:bodyPr xmlns:a="http://schemas.openxmlformats.org/drawingml/2006/main" wrap="square" lIns="0" tIns="0" rIns="0" bIns="0" anchor="t">
             <a:normAutofit fontScale="100000"/>
           </a:bodyPr>
           <a:lstStyle xmlns:a="http://schemas.openxmlformats.org/drawingml/2006/main"/>
@@ -4923,11 +4928,13 @@
               </a:defRPr>
             </a:pPr>
             <a:r>
-              <a:rPr sz="1800" b="1">
-                <a:solidFill>
-                  <a:srgbClr val="60687C"/>
-                </a:solidFill>
-                <a:latin typeface="Aptos Display"/>
+              <a:rPr sz="1400" b="1" i="0">
+                <a:solidFill>
+                  <a:srgbClr val="F2A65A"/>
+                </a:solidFill>
+                <a:latin typeface="Aptos"/>
+                <a:ea typeface="Aptos"/>
+                <a:cs typeface="Aptos"/>
               </a:rPr>
               <a:t>15%</a:t>
             </a:r>
@@ -5068,7 +5075,7 @@
           </a:ln>
         </p:spPr>
         <p:txBody>
-          <a:bodyPr xmlns:a="http://schemas.openxmlformats.org/drawingml/2006/main" wrap="square" lIns="0" tIns="0" rIns="0" bIns="0" anchor="ctr">
+          <a:bodyPr xmlns:a="http://schemas.openxmlformats.org/drawingml/2006/main" wrap="square" lIns="0" tIns="0" rIns="0" bIns="0" anchor="t">
             <a:normAutofit fontScale="100000"/>
           </a:bodyPr>
           <a:lstStyle xmlns:a="http://schemas.openxmlformats.org/drawingml/2006/main"/>
@@ -5088,11 +5095,13 @@
               </a:defRPr>
             </a:pPr>
             <a:r>
-              <a:rPr sz="1800" b="1">
-                <a:solidFill>
-                  <a:srgbClr val="60687C"/>
-                </a:solidFill>
-                <a:latin typeface="Aptos Display"/>
+              <a:rPr sz="1400" b="1" i="0">
+                <a:solidFill>
+                  <a:srgbClr val="F26674"/>
+                </a:solidFill>
+                <a:latin typeface="Aptos"/>
+                <a:ea typeface="Aptos"/>
+                <a:cs typeface="Aptos"/>
               </a:rPr>
               <a:t>10%</a:t>
             </a:r>
@@ -5278,7 +5287,7 @@
                 </a:solidFill>
                 <a:latin typeface="Aptos"/>
               </a:rPr>
-              <a:t>13</a:t>
+              <a:t>14</a:t>
             </a:r>
           </a:p>
         </p:txBody>
@@ -5446,7 +5455,7 @@
                 </a:solidFill>
                 <a:latin typeface="Aptos"/>
               </a:rPr>
-              <a:t>14 / PROPAGACIÓN DEL ERROR</a:t>
+              <a:t>15 / PROPAGACIÓN DEL ERROR</a:t>
             </a:r>
           </a:p>
         </p:txBody>
@@ -6276,7 +6285,7 @@
                 </a:solidFill>
                 <a:latin typeface="Aptos"/>
               </a:rPr>
-              <a:t>14</a:t>
+              <a:t>15</a:t>
             </a:r>
           </a:p>
         </p:txBody>
@@ -6468,7 +6477,7 @@
                 </a:solidFill>
                 <a:latin typeface="Aptos"/>
               </a:rPr>
-              <a:t>15 / RETRIEVAL</a:t>
+              <a:t>16 / RETRIEVAL</a:t>
             </a:r>
           </a:p>
         </p:txBody>
@@ -7525,7 +7534,7 @@
                 </a:solidFill>
                 <a:latin typeface="Aptos"/>
               </a:rPr>
-              <a:t>15</a:t>
+              <a:t>16</a:t>
             </a:r>
           </a:p>
         </p:txBody>
@@ -7760,7 +7769,7 @@
                 </a:solidFill>
                 <a:latin typeface="Aptos"/>
               </a:rPr>
-              <a:t>16 / RERANKING</a:t>
+              <a:t>17 / RERANKING</a:t>
             </a:r>
           </a:p>
         </p:txBody>
@@ -8373,7 +8382,7 @@
                 </a:solidFill>
                 <a:latin typeface="Aptos"/>
               </a:rPr>
-              <a:t>16</a:t>
+              <a:t>17</a:t>
             </a:r>
           </a:p>
         </p:txBody>
@@ -8589,7 +8598,7 @@
                 </a:solidFill>
                 <a:latin typeface="Aptos"/>
               </a:rPr>
-              <a:t>17 / GENERACIÓN</a:t>
+              <a:t>18 / GENERACIÓN</a:t>
             </a:r>
           </a:p>
         </p:txBody>
@@ -9600,7 +9609,7 @@
                 </a:solidFill>
                 <a:latin typeface="Aptos"/>
               </a:rPr>
-              <a:t>17</a:t>
+              <a:t>18</a:t>
             </a:r>
           </a:p>
         </p:txBody>
@@ -9689,7 +9698,7 @@
                 </a:solidFill>
                 <a:latin typeface="Aptos"/>
               </a:rPr>
-              <a:t>18 / LÍMITE TEÓRICO</a:t>
+              <a:t>19 / LÍMITE TEÓRICO</a:t>
             </a:r>
           </a:p>
         </p:txBody>
@@ -10074,7 +10083,7 @@
                 </a:solidFill>
                 <a:latin typeface="Aptos"/>
               </a:rPr>
-              <a:t>18</a:t>
+              <a:t>19</a:t>
             </a:r>
           </a:p>
         </p:txBody>
@@ -10303,7 +10312,7 @@
                 </a:solidFill>
                 <a:latin typeface="Aptos"/>
               </a:rPr>
-              <a:t>19 / CLARIFICACIÓN</a:t>
+              <a:t>20 / CLARIFICACIÓN</a:t>
             </a:r>
           </a:p>
         </p:txBody>
@@ -10688,7 +10697,7 @@
                 </a:solidFill>
                 <a:latin typeface="Aptos"/>
               </a:rPr>
-              <a:t>19</a:t>
+              <a:t>20</a:t>
             </a:r>
           </a:p>
         </p:txBody>
@@ -10825,6 +10834,51 @@
       <p:grpSpPr>
         <a:xfrm xmlns:a="http://schemas.openxmlformats.org/drawingml/2006/main"/>
       </p:grpSpPr>
+      <p:sp xmlns:a="http://schemas.openxmlformats.org/drawingml/2006/main">
+        <p:nvSpPr>
+          <p:cNvPr id="21" name="Rounded Rectangle 20"/>
+          <p:cNvSpPr/>
+          <p:nvPr/>
+        </p:nvSpPr>
+        <p:spPr>
+          <a:xfrm>
+            <a:off x="7315200" y="2103120"/>
+            <a:ext cx="3474720" cy="3803904"/>
+          </a:xfrm>
+          <a:prstGeom prst="roundRect">
+            <a:avLst/>
+          </a:prstGeom>
+          <a:solidFill>
+            <a:srgbClr val="F8F9FC"/>
+          </a:solidFill>
+          <a:ln w="12700">
+            <a:solidFill>
+              <a:srgbClr val="D9DEEA"/>
+            </a:solidFill>
+          </a:ln>
+        </p:spPr>
+        <p:style>
+          <a:lnRef idx="1">
+            <a:schemeClr val="accent1"/>
+          </a:lnRef>
+          <a:fillRef idx="3">
+            <a:schemeClr val="accent1"/>
+          </a:fillRef>
+          <a:effectRef idx="2">
+            <a:schemeClr val="accent1"/>
+          </a:effectRef>
+          <a:fontRef idx="minor">
+            <a:schemeClr val="lt1"/>
+          </a:fontRef>
+        </p:style>
+        <p:txBody>
+          <a:bodyPr rtlCol="0" anchor="ctr"/>
+          <a:lstStyle/>
+          <a:p>
+            <a:pPr algn="ctr"/>
+          </a:p>
+        </p:txBody>
+      </p:sp>
       <p:sp>
         <p:nvSpPr>
           <p:cNvPr id="1" name="">
@@ -10880,7 +10934,7 @@
                 </a:solidFill>
                 <a:latin typeface="Aptos"/>
               </a:rPr>
-              <a:t>20 / POLÍTICA DE INTERACCIÓN</a:t>
+              <a:t>21 / POLÍTICA DE INTERACCIÓN</a:t>
             </a:r>
           </a:p>
         </p:txBody>
@@ -10999,6 +11053,49 @@
         <p:spPr>
           <a:xfrm xmlns:a="http://schemas.openxmlformats.org/drawingml/2006/main">
             <a:off x="904875" y="2876550"/>
+            <a:ext cx="4524375" cy="1962150"/>
+          </a:xfrm>
+          <a:prstGeom xmlns:a="http://schemas.openxmlformats.org/drawingml/2006/main" prst="roundRect">
+            <a:avLst>
+              <a:gd name="adj" fmla="val 13592"/>
+            </a:avLst>
+          </a:prstGeom>
+          <a:solidFill xmlns:a="http://schemas.openxmlformats.org/drawingml/2006/main">
+            <a:srgbClr val="F1F3F9">
+              <a:alpha val="8000"/>
+            </a:srgbClr>
+          </a:solidFill>
+          <a:ln xmlns:a="http://schemas.openxmlformats.org/drawingml/2006/main" w="12700">
+            <a:solidFill>
+              <a:srgbClr val="D9DEEA">
+                <a:alpha val="18000"/>
+              </a:srgbClr>
+            </a:solidFill>
+            <a:prstDash val="solid"/>
+          </a:ln>
+        </p:spPr>
+        <p:txBody xmlns:a="http://schemas.openxmlformats.org/drawingml/2006/main">
+          <a:bodyPr/>
+          <a:p/>
+        </p:txBody>
+      </p:sp>
+      <p:sp>
+        <p:nvSpPr>
+          <p:cNvPr id="6" name="">
+            <a:extLst xmlns:a="http://schemas.openxmlformats.org/drawingml/2006/main">
+              <a:ext uri="{FF2B5EF4-FFF2-40B4-BE49-F238E27FC236}">
+                <a16:creationId xmlns:a16="http://schemas.microsoft.com/office/drawing/2014/main" id="{CE93BC19-FF6C-4C1F-BB35-BCCBA7516C65}"/>
+              </a:ext>
+            </a:extLst>
+          </p:cNvPr>
+          <p:cNvSpPr>
+            <a:spLocks xmlns:a="http://schemas.openxmlformats.org/drawingml/2006/main" noGrp="1"/>
+          </p:cNvSpPr>
+          <p:nvPr/>
+        </p:nvSpPr>
+        <p:spPr>
+          <a:xfrm xmlns:a="http://schemas.openxmlformats.org/drawingml/2006/main">
+            <a:off x="6762750" y="2876550"/>
             <a:ext cx="4524375" cy="1962150"/>
           </a:xfrm>
           <a:prstGeom xmlns:a="http://schemas.openxmlformats.org/drawingml/2006/main" prst="roundRect">
@@ -11027,49 +11124,6 @@
       </p:sp>
       <p:sp>
         <p:nvSpPr>
-          <p:cNvPr id="6" name="">
-            <a:extLst xmlns:a="http://schemas.openxmlformats.org/drawingml/2006/main">
-              <a:ext uri="{FF2B5EF4-FFF2-40B4-BE49-F238E27FC236}">
-                <a16:creationId xmlns:a16="http://schemas.microsoft.com/office/drawing/2014/main" id="{CE93BC19-FF6C-4C1F-BB35-BCCBA7516C65}"/>
-              </a:ext>
-            </a:extLst>
-          </p:cNvPr>
-          <p:cNvSpPr>
-            <a:spLocks xmlns:a="http://schemas.openxmlformats.org/drawingml/2006/main" noGrp="1"/>
-          </p:cNvSpPr>
-          <p:nvPr/>
-        </p:nvSpPr>
-        <p:spPr>
-          <a:xfrm xmlns:a="http://schemas.openxmlformats.org/drawingml/2006/main">
-            <a:off x="6762750" y="2876550"/>
-            <a:ext cx="4524375" cy="1962150"/>
-          </a:xfrm>
-          <a:prstGeom xmlns:a="http://schemas.openxmlformats.org/drawingml/2006/main" prst="roundRect">
-            <a:avLst>
-              <a:gd name="adj" fmla="val 13592"/>
-            </a:avLst>
-          </a:prstGeom>
-          <a:solidFill xmlns:a="http://schemas.openxmlformats.org/drawingml/2006/main">
-            <a:srgbClr val="FFFFFF">
-              <a:alpha val="8000"/>
-            </a:srgbClr>
-          </a:solidFill>
-          <a:ln xmlns:a="http://schemas.openxmlformats.org/drawingml/2006/main" w="9525">
-            <a:solidFill>
-              <a:srgbClr val="FFFFFF">
-                <a:alpha val="18000"/>
-              </a:srgbClr>
-            </a:solidFill>
-            <a:prstDash val="solid"/>
-          </a:ln>
-        </p:spPr>
-        <p:txBody xmlns:a="http://schemas.openxmlformats.org/drawingml/2006/main">
-          <a:bodyPr/>
-          <a:p/>
-        </p:txBody>
-      </p:sp>
-      <p:sp>
-        <p:nvSpPr>
           <p:cNvPr id="7" name="">
             <a:extLst xmlns:a="http://schemas.openxmlformats.org/drawingml/2006/main">
               <a:ext uri="{FF2B5EF4-FFF2-40B4-BE49-F238E27FC236}">
@@ -11757,7 +11811,7 @@
                 </a:solidFill>
                 <a:latin typeface="Aptos"/>
               </a:rPr>
-              <a:t>20</a:t>
+              <a:t>21</a:t>
             </a:r>
           </a:p>
         </p:txBody>
@@ -11863,51 +11917,6 @@
       <p:grpSpPr>
         <a:xfrm xmlns:a="http://schemas.openxmlformats.org/drawingml/2006/main"/>
       </p:grpSpPr>
-      <p:sp xmlns:a="http://schemas.openxmlformats.org/drawingml/2006/main">
-        <p:nvSpPr>
-          <p:cNvPr id="24" name="Rounded Rectangle 23"/>
-          <p:cNvSpPr/>
-          <p:nvPr/>
-        </p:nvSpPr>
-        <p:spPr>
-          <a:xfrm>
-            <a:off x="7315200" y="2103120"/>
-            <a:ext cx="3474720" cy="3803904"/>
-          </a:xfrm>
-          <a:prstGeom prst="roundRect">
-            <a:avLst/>
-          </a:prstGeom>
-          <a:solidFill>
-            <a:srgbClr val="F8F9FC"/>
-          </a:solidFill>
-          <a:ln w="12700">
-            <a:solidFill>
-              <a:srgbClr val="D9DEEA"/>
-            </a:solidFill>
-          </a:ln>
-        </p:spPr>
-        <p:style>
-          <a:lnRef idx="1">
-            <a:schemeClr val="accent1"/>
-          </a:lnRef>
-          <a:fillRef idx="3">
-            <a:schemeClr val="accent1"/>
-          </a:fillRef>
-          <a:effectRef idx="2">
-            <a:schemeClr val="accent1"/>
-          </a:effectRef>
-          <a:fontRef idx="minor">
-            <a:schemeClr val="lt1"/>
-          </a:fontRef>
-        </p:style>
-        <p:txBody>
-          <a:bodyPr rtlCol="0" anchor="ctr"/>
-          <a:lstStyle/>
-          <a:p>
-            <a:pPr algn="ctr"/>
-          </a:p>
-        </p:txBody>
-      </p:sp>
       <p:sp>
         <p:nvSpPr>
           <p:cNvPr id="1" name="">
@@ -11963,7 +11972,7 @@
                 </a:solidFill>
                 <a:latin typeface="Aptos"/>
               </a:rPr>
-              <a:t>21 / EVIDENCIA</a:t>
+              <a:t>22 / EVIDENCIA</a:t>
             </a:r>
           </a:p>
         </p:txBody>
@@ -12322,7 +12331,7 @@
           </a:ln>
         </p:spPr>
         <p:txBody>
-          <a:bodyPr xmlns:a="http://schemas.openxmlformats.org/drawingml/2006/main" wrap="square" lIns="0" tIns="0" rIns="0" bIns="0" anchor="ctr">
+          <a:bodyPr xmlns:a="http://schemas.openxmlformats.org/drawingml/2006/main" wrap="square" lIns="0" tIns="0" rIns="0" bIns="0" anchor="t">
             <a:normAutofit fontScale="100000"/>
           </a:bodyPr>
           <a:lstStyle xmlns:a="http://schemas.openxmlformats.org/drawingml/2006/main"/>
@@ -12342,11 +12351,13 @@
               </a:defRPr>
             </a:pPr>
             <a:r>
-              <a:rPr sz="2400" b="1">
-                <a:solidFill>
-                  <a:srgbClr val="7065E8"/>
+              <a:rPr sz="2800" b="1" i="0">
+                <a:solidFill>
+                  <a:srgbClr val="52C97F"/>
                 </a:solidFill>
                 <a:latin typeface="Aptos Display"/>
+                <a:ea typeface="Aptos"/>
+                <a:cs typeface="Aptos"/>
               </a:rPr>
               <a:t>54% → 67%</a:t>
             </a:r>
@@ -12444,7 +12455,7 @@
           </a:ln>
         </p:spPr>
         <p:txBody>
-          <a:bodyPr xmlns:a="http://schemas.openxmlformats.org/drawingml/2006/main" wrap="square" lIns="0" tIns="0" rIns="0" bIns="0" anchor="ctr">
+          <a:bodyPr xmlns:a="http://schemas.openxmlformats.org/drawingml/2006/main" wrap="square" lIns="0" tIns="0" rIns="0" bIns="0" anchor="t">
             <a:normAutofit fontScale="100000"/>
           </a:bodyPr>
           <a:lstStyle xmlns:a="http://schemas.openxmlformats.org/drawingml/2006/main"/>
@@ -12464,11 +12475,13 @@
               </a:defRPr>
             </a:pPr>
             <a:r>
-              <a:rPr sz="2400" b="1">
-                <a:solidFill>
-                  <a:srgbClr val="F26674"/>
+              <a:rPr sz="2800" b="1" i="0">
+                <a:solidFill>
+                  <a:srgbClr val="F2A65A"/>
                 </a:solidFill>
                 <a:latin typeface="Aptos Display"/>
+                <a:ea typeface="Aptos"/>
+                <a:cs typeface="Aptos"/>
               </a:rPr>
               <a:t>46% → 55%</a:t>
             </a:r>
@@ -12663,7 +12676,7 @@
           </a:ln>
         </p:spPr>
         <p:txBody>
-          <a:bodyPr xmlns:a="http://schemas.openxmlformats.org/drawingml/2006/main" wrap="square" lIns="0" tIns="0" rIns="0" bIns="0" anchor="ctr">
+          <a:bodyPr xmlns:a="http://schemas.openxmlformats.org/drawingml/2006/main" wrap="square" lIns="0" tIns="0" rIns="0" bIns="0" anchor="t">
             <a:normAutofit fontScale="100000"/>
           </a:bodyPr>
           <a:lstStyle xmlns:a="http://schemas.openxmlformats.org/drawingml/2006/main"/>
@@ -12683,11 +12696,13 @@
               </a:defRPr>
             </a:pPr>
             <a:r>
-              <a:rPr sz="2400" b="1">
-                <a:solidFill>
-                  <a:srgbClr val="F2A65A"/>
+              <a:rPr sz="2800" b="1" i="0">
+                <a:solidFill>
+                  <a:srgbClr val="F26674"/>
                 </a:solidFill>
                 <a:latin typeface="Aptos Display"/>
+                <a:ea typeface="Aptos"/>
+                <a:cs typeface="Aptos"/>
               </a:rPr>
               <a:t>0–2.5%</a:t>
             </a:r>
@@ -12873,7 +12888,7 @@
                 </a:solidFill>
                 <a:latin typeface="Aptos"/>
               </a:rPr>
-              <a:t>21</a:t>
+              <a:t>22</a:t>
             </a:r>
           </a:p>
         </p:txBody>
@@ -13982,7 +13997,7 @@
                 </a:solidFill>
                 <a:latin typeface="Aptos"/>
               </a:rPr>
-              <a:t>22 / DISEÑO OPERATIVO</a:t>
+              <a:t>23 / DISEÑO OPERATIVO</a:t>
             </a:r>
           </a:p>
         </p:txBody>
@@ -15404,7 +15419,7 @@
           </a:ln>
         </p:spPr>
         <p:txBody>
-          <a:bodyPr xmlns:a="http://schemas.openxmlformats.org/drawingml/2006/main" wrap="square" lIns="0" tIns="0" rIns="0" bIns="0" anchor="ctr">
+          <a:bodyPr xmlns:a="http://schemas.openxmlformats.org/drawingml/2006/main" wrap="square" lIns="0" tIns="0" rIns="0" bIns="0" anchor="t">
             <a:normAutofit fontScale="100000"/>
           </a:bodyPr>
           <a:lstStyle xmlns:a="http://schemas.openxmlformats.org/drawingml/2006/main"/>
@@ -15424,13 +15439,15 @@
               </a:defRPr>
             </a:pPr>
             <a:r>
-              <a:rPr sz="1400" b="0">
+              <a:rPr sz="1400" b="0" i="0">
                 <a:solidFill>
                   <a:srgbClr val="C7CEDF"/>
                 </a:solidFill>
                 <a:latin typeface="Aptos"/>
-              </a:rPr>
-              <a:t>Caso de Negocio  ·  Tolerancia al Error  ·  Mapeo de Intención</a:t>
+                <a:ea typeface="Aptos"/>
+                <a:cs typeface="Aptos"/>
+              </a:rPr>
+              <a:t>{Caso de uso}  ·  {Política de riesgo}  ·  {Umbral de ambigüedad}</a:t>
             </a:r>
           </a:p>
         </p:txBody>
@@ -15552,7 +15569,7 @@
                 </a:solidFill>
                 <a:latin typeface="Aptos"/>
               </a:rPr>
-              <a:t>22</a:t>
+              <a:t>23</a:t>
             </a:r>
           </a:p>
         </p:txBody>
@@ -16321,6 +16338,744 @@
 </file>
 
 <file path=ppt/slides/slide22.xml><?xml version="1.0" encoding="utf-8"?>
+<p:sld xmlns:a="http://schemas.openxmlformats.org/drawingml/2006/main" xmlns:p="http://schemas.openxmlformats.org/presentationml/2006/main" xmlns:r="http://schemas.openxmlformats.org/officeDocument/2006/relationships">
+  <p:cSld>
+    <p:bg>
+      <p:bgPr>
+        <a:solidFill>
+          <a:srgbClr val="F7F8FC"/>
+        </a:solidFill>
+        <a:effectLst/>
+      </p:bgPr>
+    </p:bg>
+    <p:spTree>
+      <p:nvGrpSpPr>
+        <p:cNvPr id="1" name=""/>
+        <p:cNvGrpSpPr/>
+        <p:nvPr/>
+      </p:nvGrpSpPr>
+      <p:grpSpPr/>
+      <p:sp>
+        <p:nvSpPr>
+          <p:cNvPr id="5" name="Rounded Rectangle 4"/>
+          <p:cNvSpPr/>
+          <p:nvPr/>
+        </p:nvSpPr>
+        <p:spPr>
+          <a:xfrm>
+            <a:off x="594360" y="1536192"/>
+            <a:ext cx="5212080" cy="2971800"/>
+          </a:xfrm>
+          <a:prstGeom prst="roundRect">
+            <a:avLst/>
+          </a:prstGeom>
+          <a:solidFill>
+            <a:srgbClr val="F0EEFF"/>
+          </a:solidFill>
+          <a:ln w="19050">
+            <a:solidFill>
+              <a:srgbClr val="7065E8"/>
+            </a:solidFill>
+          </a:ln>
+        </p:spPr>
+        <p:style>
+          <a:lnRef idx="1">
+            <a:schemeClr val="accent1"/>
+          </a:lnRef>
+          <a:fillRef idx="3">
+            <a:schemeClr val="accent1"/>
+          </a:fillRef>
+          <a:effectRef idx="2">
+            <a:schemeClr val="accent1"/>
+          </a:effectRef>
+          <a:fontRef idx="minor">
+            <a:schemeClr val="lt1"/>
+          </a:fontRef>
+        </p:style>
+        <p:txBody>
+          <a:bodyPr rtlCol="0" anchor="ctr"/>
+          <a:lstStyle/>
+          <a:p>
+            <a:pPr algn="ctr"/>
+          </a:p>
+        </p:txBody>
+      </p:sp>
+      <p:sp>
+        <p:nvSpPr>
+          <p:cNvPr id="10" name="Rounded Rectangle 9"/>
+          <p:cNvSpPr/>
+          <p:nvPr/>
+        </p:nvSpPr>
+        <p:spPr>
+          <a:xfrm>
+            <a:off x="6172200" y="1536192"/>
+            <a:ext cx="5212080" cy="2971800"/>
+          </a:xfrm>
+          <a:prstGeom prst="roundRect">
+            <a:avLst/>
+          </a:prstGeom>
+          <a:solidFill>
+            <a:srgbClr val="FFF7F7"/>
+          </a:solidFill>
+          <a:ln w="19050">
+            <a:solidFill>
+              <a:srgbClr val="F26674"/>
+            </a:solidFill>
+          </a:ln>
+        </p:spPr>
+        <p:style>
+          <a:lnRef idx="1">
+            <a:schemeClr val="accent1"/>
+          </a:lnRef>
+          <a:fillRef idx="3">
+            <a:schemeClr val="accent1"/>
+          </a:fillRef>
+          <a:effectRef idx="2">
+            <a:schemeClr val="accent1"/>
+          </a:effectRef>
+          <a:fontRef idx="minor">
+            <a:schemeClr val="lt1"/>
+          </a:fontRef>
+        </p:style>
+        <p:txBody>
+          <a:bodyPr rtlCol="0" anchor="ctr"/>
+          <a:lstStyle/>
+          <a:p>
+            <a:pPr algn="ctr"/>
+          </a:p>
+        </p:txBody>
+      </p:sp>
+      <p:sp>
+        <p:nvSpPr>
+          <p:cNvPr id="2" name="TextBox 1"/>
+          <p:cNvSpPr txBox="1"/>
+          <p:nvPr/>
+        </p:nvSpPr>
+        <p:spPr>
+          <a:xfrm>
+            <a:off x="685800" y="365760"/>
+            <a:ext cx="5943600" cy="219456"/>
+          </a:xfrm>
+          <a:prstGeom prst="rect">
+            <a:avLst/>
+          </a:prstGeom>
+          <a:noFill/>
+        </p:spPr>
+        <p:txBody>
+          <a:bodyPr wrap="square" lIns="0" rIns="0" tIns="0" bIns="0" anchor="ctr">
+            <a:spAutoFit/>
+          </a:bodyPr>
+          <a:lstStyle/>
+          <a:p>
+            <a:pPr algn="l"/>
+            <a:r>
+              <a:rPr sz="1200" b="1">
+                <a:solidFill>
+                  <a:srgbClr val="7065E8"/>
+                </a:solidFill>
+                <a:latin typeface="Aptos"/>
+              </a:rPr>
+              <a:t>11 / CHAIN-OF-THOUGHT</a:t>
+            </a:r>
+          </a:p>
+        </p:txBody>
+      </p:sp>
+      <p:sp>
+        <p:nvSpPr>
+          <p:cNvPr id="3" name="TextBox 2"/>
+          <p:cNvSpPr txBox="1"/>
+          <p:nvPr/>
+        </p:nvSpPr>
+        <p:spPr>
+          <a:xfrm>
+            <a:off x="685800" y="694944"/>
+            <a:ext cx="10835640" cy="585216"/>
+          </a:xfrm>
+          <a:prstGeom prst="rect">
+            <a:avLst/>
+          </a:prstGeom>
+          <a:noFill/>
+        </p:spPr>
+        <p:txBody>
+          <a:bodyPr wrap="square" lIns="0" rIns="0" tIns="0" bIns="0" anchor="ctr">
+            <a:spAutoFit/>
+          </a:bodyPr>
+          <a:lstStyle/>
+          <a:p>
+            <a:pPr algn="l"/>
+            <a:r>
+              <a:rPr sz="3400" b="1">
+                <a:solidFill>
+                  <a:srgbClr val="101526"/>
+                </a:solidFill>
+                <a:latin typeface="Aptos Display"/>
+              </a:rPr>
+              <a:t>Chain-of-Thought extiende el prefijo y reduce la entropía</a:t>
+            </a:r>
+          </a:p>
+        </p:txBody>
+      </p:sp>
+      <p:sp>
+        <p:nvSpPr>
+          <p:cNvPr id="4" name="Rectangle 3"/>
+          <p:cNvSpPr/>
+          <p:nvPr/>
+        </p:nvSpPr>
+        <p:spPr>
+          <a:xfrm>
+            <a:off x="685800" y="1417320"/>
+            <a:ext cx="10817352" cy="10972"/>
+          </a:xfrm>
+          <a:prstGeom prst="rect">
+            <a:avLst/>
+          </a:prstGeom>
+          <a:solidFill>
+            <a:srgbClr val="D9DEEA"/>
+          </a:solidFill>
+          <a:ln>
+            <a:noFill/>
+          </a:ln>
+        </p:spPr>
+        <p:style>
+          <a:lnRef idx="1">
+            <a:schemeClr val="accent1"/>
+          </a:lnRef>
+          <a:fillRef idx="3">
+            <a:schemeClr val="accent1"/>
+          </a:fillRef>
+          <a:effectRef idx="2">
+            <a:schemeClr val="accent1"/>
+          </a:effectRef>
+          <a:fontRef idx="minor">
+            <a:schemeClr val="lt1"/>
+          </a:fontRef>
+        </p:style>
+        <p:txBody>
+          <a:bodyPr rtlCol="0" anchor="ctr"/>
+          <a:lstStyle/>
+          <a:p>
+            <a:pPr algn="ctr"/>
+          </a:p>
+        </p:txBody>
+      </p:sp>
+      <p:sp>
+        <p:nvSpPr>
+          <p:cNvPr id="6" name="TextBox 5"/>
+          <p:cNvSpPr txBox="1"/>
+          <p:nvPr/>
+        </p:nvSpPr>
+        <p:spPr>
+          <a:xfrm>
+            <a:off x="713232" y="1627632"/>
+            <a:ext cx="4983480" cy="320040"/>
+          </a:xfrm>
+          <a:prstGeom prst="rect">
+            <a:avLst/>
+          </a:prstGeom>
+          <a:noFill/>
+        </p:spPr>
+        <p:txBody>
+          <a:bodyPr wrap="square" lIns="0" rIns="0" tIns="0" bIns="0" anchor="ctr">
+            <a:spAutoFit/>
+          </a:bodyPr>
+          <a:lstStyle/>
+          <a:p>
+            <a:pPr algn="l"/>
+            <a:r>
+              <a:rPr sz="1600" b="1">
+                <a:solidFill>
+                  <a:srgbClr val="7065E8"/>
+                </a:solidFill>
+                <a:latin typeface="Aptos"/>
+              </a:rPr>
+              <a:t>1. Fundamento Probabilístico</a:t>
+            </a:r>
+          </a:p>
+        </p:txBody>
+      </p:sp>
+      <p:pic>
+        <p:nvPicPr>
+          <p:cNvPr id="7" name="Ecuación s_cot_formula" descr="s_cot_formula.png"/>
+          <p:cNvPicPr>
+            <a:picLocks noChangeAspect="1"/>
+          </p:cNvPicPr>
+          <p:nvPr/>
+        </p:nvPicPr>
+        <p:blipFill>
+          <a:blip r:embed="rId2"/>
+          <a:stretch>
+            <a:fillRect/>
+          </a:stretch>
+        </p:blipFill>
+        <p:spPr>
+          <a:xfrm>
+            <a:off x="1097031" y="1993392"/>
+            <a:ext cx="4215882" cy="566928"/>
+          </a:xfrm>
+          <a:prstGeom prst="rect">
+            <a:avLst/>
+          </a:prstGeom>
+        </p:spPr>
+      </p:pic>
+      <p:pic>
+        <p:nvPicPr>
+          <p:cNvPr id="8" name="Ecuación s_cot_entropy" descr="s_cot_entropy.png"/>
+          <p:cNvPicPr>
+            <a:picLocks noChangeAspect="1"/>
+          </p:cNvPicPr>
+          <p:nvPr/>
+        </p:nvPicPr>
+        <p:blipFill>
+          <a:blip r:embed="rId3"/>
+          <a:stretch>
+            <a:fillRect/>
+          </a:stretch>
+        </p:blipFill>
+        <p:spPr>
+          <a:xfrm>
+            <a:off x="1334110" y="2606040"/>
+            <a:ext cx="3741724" cy="384048"/>
+          </a:xfrm>
+          <a:prstGeom prst="rect">
+            <a:avLst/>
+          </a:prstGeom>
+        </p:spPr>
+      </p:pic>
+      <p:sp>
+        <p:nvSpPr>
+          <p:cNvPr id="9" name="TextBox 8"/>
+          <p:cNvSpPr txBox="1"/>
+          <p:nvPr/>
+        </p:nvSpPr>
+        <p:spPr>
+          <a:xfrm>
+            <a:off x="713232" y="3063240"/>
+            <a:ext cx="4983480" cy="1371600"/>
+          </a:xfrm>
+          <a:prstGeom prst="rect">
+            <a:avLst/>
+          </a:prstGeom>
+          <a:noFill/>
+        </p:spPr>
+        <p:txBody>
+          <a:bodyPr wrap="square">
+            <a:spAutoFit/>
+          </a:bodyPr>
+          <a:lstStyle/>
+          <a:p>
+            <a:r>
+              <a:rPr sz="1200" b="1">
+                <a:solidFill>
+                  <a:srgbClr val="101526"/>
+                </a:solidFill>
+                <a:latin typeface="Aptos"/>
+              </a:rPr>
+              <a:t>• Prefijo extendido y&lt;t: </a:t>
+            </a:r>
+            <a:r>
+              <a:rPr sz="1150">
+                <a:solidFill>
+                  <a:srgbClr val="60687C"/>
+                </a:solidFill>
+                <a:latin typeface="Aptos"/>
+              </a:rPr>
+              <a:t>Los tokens de razonamiento R=(r₁..rₘ) se incorporan a la historia autoregresiva antes de generar Y.
+</a:t>
+            </a:r>
+          </a:p>
+          <a:p>
+            <a:r>
+              <a:rPr sz="1200" b="1">
+                <a:solidFill>
+                  <a:srgbClr val="101526"/>
+                </a:solidFill>
+                <a:latin typeface="Aptos"/>
+              </a:rPr>
+              <a:t>• Pasos de atención extra: </a:t>
+            </a:r>
+            <a:r>
+              <a:rPr sz="1150">
+                <a:solidFill>
+                  <a:srgbClr val="60687C"/>
+                </a:solidFill>
+                <a:latin typeface="Aptos"/>
+              </a:rPr>
+              <a:t>Cada token r_t brinda un paso de cómputo adicional para integrar la evidencia de X y C.</a:t>
+            </a:r>
+          </a:p>
+        </p:txBody>
+      </p:sp>
+      <p:sp>
+        <p:nvSpPr>
+          <p:cNvPr id="11" name="TextBox 10"/>
+          <p:cNvSpPr txBox="1"/>
+          <p:nvPr/>
+        </p:nvSpPr>
+        <p:spPr>
+          <a:xfrm>
+            <a:off x="6291072" y="1627632"/>
+            <a:ext cx="4983480" cy="320040"/>
+          </a:xfrm>
+          <a:prstGeom prst="rect">
+            <a:avLst/>
+          </a:prstGeom>
+          <a:noFill/>
+        </p:spPr>
+        <p:txBody>
+          <a:bodyPr wrap="square" lIns="0" rIns="0" tIns="0" bIns="0" anchor="ctr">
+            <a:spAutoFit/>
+          </a:bodyPr>
+          <a:lstStyle/>
+          <a:p>
+            <a:pPr algn="l"/>
+            <a:r>
+              <a:rPr sz="1600" b="1">
+                <a:solidFill>
+                  <a:srgbClr val="F26674"/>
+                </a:solidFill>
+                <a:latin typeface="Aptos"/>
+              </a:rPr>
+              <a:t>2. Límites y Riesgos de CoT</a:t>
+            </a:r>
+          </a:p>
+        </p:txBody>
+      </p:sp>
+      <p:sp>
+        <p:nvSpPr>
+          <p:cNvPr id="12" name="Rounded Rectangle 11"/>
+          <p:cNvSpPr/>
+          <p:nvPr/>
+        </p:nvSpPr>
+        <p:spPr>
+          <a:xfrm>
+            <a:off x="6291072" y="2011680"/>
+            <a:ext cx="4974336" cy="1170432"/>
+          </a:xfrm>
+          <a:prstGeom prst="roundRect">
+            <a:avLst/>
+          </a:prstGeom>
+          <a:solidFill>
+            <a:srgbClr val="FDF0F0"/>
+          </a:solidFill>
+          <a:ln w="12700">
+            <a:solidFill>
+              <a:srgbClr val="F26674"/>
+            </a:solidFill>
+          </a:ln>
+        </p:spPr>
+        <p:style>
+          <a:lnRef idx="1">
+            <a:schemeClr val="accent1"/>
+          </a:lnRef>
+          <a:fillRef idx="3">
+            <a:schemeClr val="accent1"/>
+          </a:fillRef>
+          <a:effectRef idx="2">
+            <a:schemeClr val="accent1"/>
+          </a:effectRef>
+          <a:fontRef idx="minor">
+            <a:schemeClr val="lt1"/>
+          </a:fontRef>
+        </p:style>
+        <p:txBody>
+          <a:bodyPr rtlCol="0" anchor="ctr"/>
+          <a:lstStyle/>
+          <a:p>
+            <a:pPr algn="ctr"/>
+          </a:p>
+        </p:txBody>
+      </p:sp>
+      <p:sp>
+        <p:nvSpPr>
+          <p:cNvPr id="13" name="TextBox 12"/>
+          <p:cNvSpPr txBox="1"/>
+          <p:nvPr/>
+        </p:nvSpPr>
+        <p:spPr>
+          <a:xfrm>
+            <a:off x="6382512" y="2057400"/>
+            <a:ext cx="4791456" cy="1078992"/>
+          </a:xfrm>
+          <a:prstGeom prst="rect">
+            <a:avLst/>
+          </a:prstGeom>
+          <a:noFill/>
+        </p:spPr>
+        <p:txBody>
+          <a:bodyPr wrap="square">
+            <a:spAutoFit/>
+          </a:bodyPr>
+          <a:lstStyle/>
+          <a:p>
+            <a:r>
+              <a:rPr sz="1300" b="1">
+                <a:solidFill>
+                  <a:srgbClr val="F26674"/>
+                </a:solidFill>
+                <a:latin typeface="Aptos"/>
+              </a:rPr>
+              <a:t>Cascada de Errores (Error Propagation)
+</a:t>
+            </a:r>
+            <a:r>
+              <a:rPr sz="1150">
+                <a:solidFill>
+                  <a:srgbClr val="60687C"/>
+                </a:solidFill>
+                <a:latin typeface="Aptos"/>
+              </a:rPr>
+              <a:t>Un fallo o alucinación en r₁ o r₂ queda fijado en y&lt;t. Por autoconsistencia, el modelo se condiciona a justificar una respuesta final errónea.</a:t>
+            </a:r>
+          </a:p>
+        </p:txBody>
+      </p:sp>
+      <p:sp>
+        <p:nvSpPr>
+          <p:cNvPr id="14" name="Rounded Rectangle 13"/>
+          <p:cNvSpPr/>
+          <p:nvPr/>
+        </p:nvSpPr>
+        <p:spPr>
+          <a:xfrm>
+            <a:off x="6291072" y="3246120"/>
+            <a:ext cx="4974336" cy="1170432"/>
+          </a:xfrm>
+          <a:prstGeom prst="roundRect">
+            <a:avLst/>
+          </a:prstGeom>
+          <a:solidFill>
+            <a:srgbClr val="FFF7EE"/>
+          </a:solidFill>
+          <a:ln w="12700">
+            <a:solidFill>
+              <a:srgbClr val="F2A65A"/>
+            </a:solidFill>
+          </a:ln>
+        </p:spPr>
+        <p:style>
+          <a:lnRef idx="1">
+            <a:schemeClr val="accent1"/>
+          </a:lnRef>
+          <a:fillRef idx="3">
+            <a:schemeClr val="accent1"/>
+          </a:fillRef>
+          <a:effectRef idx="2">
+            <a:schemeClr val="accent1"/>
+          </a:effectRef>
+          <a:fontRef idx="minor">
+            <a:schemeClr val="lt1"/>
+          </a:fontRef>
+        </p:style>
+        <p:txBody>
+          <a:bodyPr rtlCol="0" anchor="ctr"/>
+          <a:lstStyle/>
+          <a:p>
+            <a:pPr algn="ctr"/>
+          </a:p>
+        </p:txBody>
+      </p:sp>
+      <p:sp>
+        <p:nvSpPr>
+          <p:cNvPr id="15" name="TextBox 14"/>
+          <p:cNvSpPr txBox="1"/>
+          <p:nvPr/>
+        </p:nvSpPr>
+        <p:spPr>
+          <a:xfrm>
+            <a:off x="6382512" y="3291840"/>
+            <a:ext cx="4791456" cy="1078992"/>
+          </a:xfrm>
+          <a:prstGeom prst="rect">
+            <a:avLst/>
+          </a:prstGeom>
+          <a:noFill/>
+        </p:spPr>
+        <p:txBody>
+          <a:bodyPr wrap="square">
+            <a:spAutoFit/>
+          </a:bodyPr>
+          <a:lstStyle/>
+          <a:p>
+            <a:r>
+              <a:rPr sz="1300" b="1">
+                <a:solidFill>
+                  <a:srgbClr val="F2A65A"/>
+                </a:solidFill>
+                <a:latin typeface="Aptos"/>
+              </a:rPr>
+              <a:t>Overthinking y Ruido en el Contexto
+</a:t>
+            </a:r>
+            <a:r>
+              <a:rPr sz="1150">
+                <a:solidFill>
+                  <a:srgbClr val="60687C"/>
+                </a:solidFill>
+                <a:latin typeface="Aptos"/>
+              </a:rPr>
+              <a:t>Un razonamiento excesivamente largo infla |C|, inyectando ruido N(C) y reduciendo la densidad de señal útil por token I(Y;C|X)/|C|.</a:t>
+            </a:r>
+          </a:p>
+        </p:txBody>
+      </p:sp>
+      <p:sp>
+        <p:nvSpPr>
+          <p:cNvPr id="16" name="TextBox 15"/>
+          <p:cNvSpPr txBox="1"/>
+          <p:nvPr/>
+        </p:nvSpPr>
+        <p:spPr>
+          <a:xfrm>
+            <a:off x="1051560" y="4590288"/>
+            <a:ext cx="10058400" cy="502920"/>
+          </a:xfrm>
+          <a:prstGeom prst="rect">
+            <a:avLst/>
+          </a:prstGeom>
+          <a:noFill/>
+        </p:spPr>
+        <p:txBody>
+          <a:bodyPr wrap="square" lIns="0" rIns="0" tIns="0" bIns="0" anchor="ctr">
+            <a:spAutoFit/>
+          </a:bodyPr>
+          <a:lstStyle/>
+          <a:p>
+            <a:pPr algn="ctr"/>
+            <a:r>
+              <a:rPr sz="1700" b="1">
+                <a:solidFill>
+                  <a:srgbClr val="7065E8"/>
+                </a:solidFill>
+                <a:latin typeface="Aptos Display"/>
+              </a:rPr>
+              <a:t>CoT maximiza la probabilidad en tareas complejas descomponiendo la inferencia, pero no resuelve la ambigüedad original si la consulta X es indeterminada.</a:t>
+            </a:r>
+          </a:p>
+        </p:txBody>
+      </p:sp>
+      <p:sp>
+        <p:nvSpPr>
+          <p:cNvPr id="17" name="TextBox 16"/>
+          <p:cNvSpPr txBox="1"/>
+          <p:nvPr/>
+        </p:nvSpPr>
+        <p:spPr>
+          <a:xfrm>
+            <a:off x="713232" y="5257800"/>
+            <a:ext cx="10561320" cy="658368"/>
+          </a:xfrm>
+          <a:prstGeom prst="rect">
+            <a:avLst/>
+          </a:prstGeom>
+          <a:noFill/>
+        </p:spPr>
+        <p:txBody>
+          <a:bodyPr wrap="square" lIns="0" rIns="0" tIns="0" bIns="0" anchor="ctr">
+            <a:spAutoFit/>
+          </a:bodyPr>
+          <a:lstStyle/>
+          <a:p>
+            <a:pPr algn="l"/>
+            <a:r>
+              <a:rPr sz="1150" b="1">
+                <a:solidFill>
+                  <a:srgbClr val="7065E8"/>
+                </a:solidFill>
+                <a:latin typeface="Aptos"/>
+              </a:rPr>
+              <a:t>Notación · </a:t>
+            </a:r>
+            <a:r>
+              <a:rPr sz="1150">
+                <a:solidFill>
+                  <a:srgbClr val="60687C"/>
+                </a:solidFill>
+                <a:latin typeface="Aptos"/>
+              </a:rPr>
+              <a:t>X consulta · C contexto · R tokens de razonamiento · Y respuesta final · H entropía condicional · N ruido en el prompt</a:t>
+            </a:r>
+          </a:p>
+        </p:txBody>
+      </p:sp>
+      <p:sp>
+        <p:nvSpPr>
+          <p:cNvPr id="18" name="TextBox 17"/>
+          <p:cNvSpPr txBox="1"/>
+          <p:nvPr/>
+        </p:nvSpPr>
+        <p:spPr>
+          <a:xfrm>
+            <a:off x="685800" y="6437376"/>
+            <a:ext cx="9966960" cy="182880"/>
+          </a:xfrm>
+          <a:prstGeom prst="rect">
+            <a:avLst/>
+          </a:prstGeom>
+          <a:noFill/>
+        </p:spPr>
+        <p:txBody>
+          <a:bodyPr wrap="square" lIns="0" rIns="0" tIns="0" bIns="0" anchor="ctr">
+            <a:spAutoFit/>
+          </a:bodyPr>
+          <a:lstStyle/>
+          <a:p>
+            <a:pPr algn="l"/>
+            <a:r>
+              <a:rPr sz="1050" b="0">
+                <a:solidFill>
+                  <a:srgbClr val="8E96AA"/>
+                </a:solidFill>
+                <a:latin typeface="Aptos"/>
+              </a:rPr>
+              <a:t>Fuente: context.md — razonamiento autoregresivo, descomposición Bayesiana y análisis de riesgos de CoT</a:t>
+            </a:r>
+          </a:p>
+        </p:txBody>
+      </p:sp>
+      <p:sp>
+        <p:nvSpPr>
+          <p:cNvPr id="19" name="TextBox 18"/>
+          <p:cNvSpPr txBox="1"/>
+          <p:nvPr/>
+        </p:nvSpPr>
+        <p:spPr>
+          <a:xfrm>
+            <a:off x="11045952" y="6419088"/>
+            <a:ext cx="457200" cy="201168"/>
+          </a:xfrm>
+          <a:prstGeom prst="rect">
+            <a:avLst/>
+          </a:prstGeom>
+          <a:noFill/>
+        </p:spPr>
+        <p:txBody>
+          <a:bodyPr wrap="square" lIns="0" rIns="0" tIns="0" bIns="0" anchor="ctr">
+            <a:spAutoFit/>
+          </a:bodyPr>
+          <a:lstStyle/>
+          <a:p>
+            <a:pPr algn="r"/>
+            <a:r>
+              <a:rPr sz="1100" b="1">
+                <a:solidFill>
+                  <a:srgbClr val="8E96AA"/>
+                </a:solidFill>
+                <a:latin typeface="Aptos"/>
+              </a:rPr>
+              <a:t>11</a:t>
+            </a:r>
+          </a:p>
+        </p:txBody>
+      </p:sp>
+    </p:spTree>
+  </p:cSld>
+  <p:clrMapOvr>
+    <a:masterClrMapping/>
+  </p:clrMapOvr>
+</p:sld>
+</file>
+
+<file path=ppt/slides/slide23.xml><?xml version="1.0" encoding="utf-8"?>
 <p:sld xmlns:a="http://schemas.openxmlformats.org/drawingml/2006/main" xmlns:p="http://schemas.openxmlformats.org/presentationml/2006/main" xmlns:r="http://schemas.openxmlformats.org/officeDocument/2006/relationships">
   <p:cSld>
     <p:bg>
@@ -19546,8 +20301,8 @@
         </p:blipFill>
         <p:spPr>
           <a:xfrm>
-            <a:off x="6953250" y="4342004"/>
-            <a:ext cx="3810000" cy="307591"/>
+            <a:off x="6953250" y="4341086"/>
+            <a:ext cx="3810000" cy="309427"/>
           </a:xfrm>
           <a:prstGeom prst="rect">
             <a:avLst/>
@@ -19557,6 +20312,50 @@
       <p:sp xmlns:a="http://schemas.openxmlformats.org/drawingml/2006/main">
         <p:nvSpPr>
           <p:cNvPr id="21" name="TextBox 20"/>
+          <p:cNvSpPr txBox="1"/>
+          <p:nvPr/>
+        </p:nvSpPr>
+        <p:spPr>
+          <a:xfrm>
+            <a:off x="5029200" y="2121408"/>
+            <a:ext cx="2926080" cy="292608"/>
+          </a:xfrm>
+          <a:prstGeom prst="rect">
+            <a:avLst/>
+          </a:prstGeom>
+          <a:noFill/>
+        </p:spPr>
+        <p:txBody>
+          <a:bodyPr wrap="square" lIns="0" rIns="0" tIns="0" bIns="0" anchor="ctr">
+            <a:spAutoFit/>
+          </a:bodyPr>
+          <a:lstStyle/>
+          <a:p>
+            <a:pPr algn="l"/>
+            <a:r>
+              <a:rPr sz="1150" b="1">
+                <a:solidFill>
+                  <a:srgbClr val="7065E8"/>
+                </a:solidFill>
+                <a:latin typeface="Aptos"/>
+              </a:rPr>
+              <a:t>Consulta (X): </a:t>
+            </a:r>
+            <a:r>
+              <a:rPr sz="1150" i="1">
+                <a:solidFill>
+                  <a:srgbClr val="101526"/>
+                </a:solidFill>
+                <a:latin typeface="Aptos"/>
+              </a:rPr>
+              <a:t>«¿Cuánto dura la garantía?»</a:t>
+            </a:r>
+          </a:p>
+        </p:txBody>
+      </p:sp>
+      <p:sp xmlns:a="http://schemas.openxmlformats.org/drawingml/2006/main">
+        <p:nvSpPr>
+          <p:cNvPr id="22" name="TextBox 21"/>
           <p:cNvSpPr txBox="1"/>
           <p:nvPr/>
         </p:nvSpPr>
@@ -19593,7 +20392,7 @@
                 </a:solidFill>
                 <a:latin typeface="Aptos"/>
               </a:rPr>
-              <a:t>θ parámetros del LLM · t posición · yₜ token actual · y&lt;ₜ prefijo generado</a:t>
+              <a:t>θ parámetros · t posición · yₜ token actual · X consulta («¿Cuánto dura la garantía?») · C contexto (contrato)</a:t>
             </a:r>
           </a:p>
         </p:txBody>
@@ -20511,8 +21310,8 @@
                 </a:solidFill>
                 <a:latin typeface="Aptos"/>
               </a:rPr>
-              <a:t>H entropía · I información mutua · X consulta · Y respuesta · C contexto
-Válido para un predictor ideal, en promedio sobre C.</a:t>
+              <a:t>H entropía (incertidumbre) · I información mutua condicional · X consulta · Y respuesta · C contexto
+El contexto es valioso cuando reduce la incertidumbre sobre la respuesta Y.</a:t>
             </a:r>
           </a:p>
         </p:txBody>

</xml_diff>